<commit_message>
More projects & implementation english
</commit_message>
<xml_diff>
--- a/assets/project/project.pptx
+++ b/assets/project/project.pptx
@@ -6,7 +6,7 @@
   </p:sldMasterIdLst>
   <p:sldIdLst>
     <p:sldId id="276" r:id="rId2"/>
-    <p:sldId id="275" r:id="rId3"/>
+    <p:sldId id="283" r:id="rId3"/>
   </p:sldIdLst>
   <p:sldSz cx="12192000" cy="6858000"/>
   <p:notesSz cx="6858000" cy="9144000"/>
@@ -105,6 +105,11 @@
       </a:defRPr>
     </a:lvl9pPr>
   </p:defaultTextStyle>
+  <p:extLst>
+    <p:ext uri="{EFAFB233-063F-42B5-8137-9DF3F51BA10A}">
+      <p15:sldGuideLst xmlns:p15="http://schemas.microsoft.com/office/powerpoint/2012/main"/>
+    </p:ext>
+  </p:extLst>
 </p:presentation>
 </file>
 
@@ -255,7 +260,7 @@
           <a:p>
             <a:fld id="{045D4A40-7BDB-4F70-A797-96ACB408B356}" type="datetimeFigureOut">
               <a:rPr lang="fr-FR" smtClean="0"/>
-              <a:t>02/11/2025</a:t>
+              <a:t>15/11/2025</a:t>
             </a:fld>
             <a:endParaRPr lang="fr-FR"/>
           </a:p>
@@ -453,7 +458,7 @@
           <a:p>
             <a:fld id="{045D4A40-7BDB-4F70-A797-96ACB408B356}" type="datetimeFigureOut">
               <a:rPr lang="fr-FR" smtClean="0"/>
-              <a:t>02/11/2025</a:t>
+              <a:t>15/11/2025</a:t>
             </a:fld>
             <a:endParaRPr lang="fr-FR"/>
           </a:p>
@@ -661,7 +666,7 @@
           <a:p>
             <a:fld id="{045D4A40-7BDB-4F70-A797-96ACB408B356}" type="datetimeFigureOut">
               <a:rPr lang="fr-FR" smtClean="0"/>
-              <a:t>02/11/2025</a:t>
+              <a:t>15/11/2025</a:t>
             </a:fld>
             <a:endParaRPr lang="fr-FR"/>
           </a:p>
@@ -859,7 +864,7 @@
           <a:p>
             <a:fld id="{045D4A40-7BDB-4F70-A797-96ACB408B356}" type="datetimeFigureOut">
               <a:rPr lang="fr-FR" smtClean="0"/>
-              <a:t>02/11/2025</a:t>
+              <a:t>15/11/2025</a:t>
             </a:fld>
             <a:endParaRPr lang="fr-FR"/>
           </a:p>
@@ -1134,7 +1139,7 @@
           <a:p>
             <a:fld id="{045D4A40-7BDB-4F70-A797-96ACB408B356}" type="datetimeFigureOut">
               <a:rPr lang="fr-FR" smtClean="0"/>
-              <a:t>02/11/2025</a:t>
+              <a:t>15/11/2025</a:t>
             </a:fld>
             <a:endParaRPr lang="fr-FR"/>
           </a:p>
@@ -1399,7 +1404,7 @@
           <a:p>
             <a:fld id="{045D4A40-7BDB-4F70-A797-96ACB408B356}" type="datetimeFigureOut">
               <a:rPr lang="fr-FR" smtClean="0"/>
-              <a:t>02/11/2025</a:t>
+              <a:t>15/11/2025</a:t>
             </a:fld>
             <a:endParaRPr lang="fr-FR"/>
           </a:p>
@@ -1811,7 +1816,7 @@
           <a:p>
             <a:fld id="{045D4A40-7BDB-4F70-A797-96ACB408B356}" type="datetimeFigureOut">
               <a:rPr lang="fr-FR" smtClean="0"/>
-              <a:t>02/11/2025</a:t>
+              <a:t>15/11/2025</a:t>
             </a:fld>
             <a:endParaRPr lang="fr-FR"/>
           </a:p>
@@ -1952,7 +1957,7 @@
           <a:p>
             <a:fld id="{045D4A40-7BDB-4F70-A797-96ACB408B356}" type="datetimeFigureOut">
               <a:rPr lang="fr-FR" smtClean="0"/>
-              <a:t>02/11/2025</a:t>
+              <a:t>15/11/2025</a:t>
             </a:fld>
             <a:endParaRPr lang="fr-FR"/>
           </a:p>
@@ -2065,7 +2070,7 @@
           <a:p>
             <a:fld id="{045D4A40-7BDB-4F70-A797-96ACB408B356}" type="datetimeFigureOut">
               <a:rPr lang="fr-FR" smtClean="0"/>
-              <a:t>02/11/2025</a:t>
+              <a:t>15/11/2025</a:t>
             </a:fld>
             <a:endParaRPr lang="fr-FR"/>
           </a:p>
@@ -2376,7 +2381,7 @@
           <a:p>
             <a:fld id="{045D4A40-7BDB-4F70-A797-96ACB408B356}" type="datetimeFigureOut">
               <a:rPr lang="fr-FR" smtClean="0"/>
-              <a:t>02/11/2025</a:t>
+              <a:t>15/11/2025</a:t>
             </a:fld>
             <a:endParaRPr lang="fr-FR"/>
           </a:p>
@@ -2664,7 +2669,7 @@
           <a:p>
             <a:fld id="{045D4A40-7BDB-4F70-A797-96ACB408B356}" type="datetimeFigureOut">
               <a:rPr lang="fr-FR" smtClean="0"/>
-              <a:t>02/11/2025</a:t>
+              <a:t>15/11/2025</a:t>
             </a:fld>
             <a:endParaRPr lang="fr-FR"/>
           </a:p>
@@ -2905,7 +2910,7 @@
           <a:p>
             <a:fld id="{045D4A40-7BDB-4F70-A797-96ACB408B356}" type="datetimeFigureOut">
               <a:rPr lang="fr-FR" smtClean="0"/>
-              <a:t>02/11/2025</a:t>
+              <a:t>15/11/2025</a:t>
             </a:fld>
             <a:endParaRPr lang="fr-FR"/>
           </a:p>
@@ -3606,8 +3611,103 @@
         </p:nvSpPr>
         <p:spPr>
           <a:xfrm>
-            <a:off x="3769753" y="25729"/>
-            <a:ext cx="4443973" cy="923330"/>
+            <a:off x="5899371" y="25729"/>
+            <a:ext cx="184731" cy="923330"/>
+          </a:xfrm>
+          <a:prstGeom prst="rect">
+            <a:avLst/>
+          </a:prstGeom>
+          <a:noFill/>
+        </p:spPr>
+        <p:txBody>
+          <a:bodyPr wrap="none" lIns="91440" tIns="45720" rIns="91440" bIns="45720">
+            <a:spAutoFit/>
+          </a:bodyPr>
+          <a:lstStyle/>
+          <a:p>
+            <a:pPr algn="ctr"/>
+            <a:endParaRPr lang="fr-FR" sz="5400" b="1" dirty="0">
+              <a:ln w="10160">
+                <a:solidFill>
+                  <a:schemeClr val="tx1"/>
+                </a:solidFill>
+                <a:prstDash val="solid"/>
+              </a:ln>
+              <a:solidFill>
+                <a:srgbClr val="FFFFFF"/>
+              </a:solidFill>
+              <a:effectLst>
+                <a:outerShdw blurRad="50800" dist="38100" dir="2700000" algn="tl" rotWithShape="0">
+                  <a:prstClr val="black">
+                    <a:alpha val="40000"/>
+                  </a:prstClr>
+                </a:outerShdw>
+              </a:effectLst>
+            </a:endParaRPr>
+          </a:p>
+        </p:txBody>
+      </p:sp>
+      <p:pic>
+        <p:nvPicPr>
+          <p:cNvPr id="13316" name="Picture 4">
+            <a:extLst>
+              <a:ext uri="{FF2B5EF4-FFF2-40B4-BE49-F238E27FC236}">
+                <a16:creationId xmlns:a16="http://schemas.microsoft.com/office/drawing/2014/main" id="{659C925D-E740-E84A-577B-C42F00BF5132}"/>
+              </a:ext>
+            </a:extLst>
+          </p:cNvPr>
+          <p:cNvPicPr>
+            <a:picLocks noChangeAspect="1" noChangeArrowheads="1"/>
+          </p:cNvPicPr>
+          <p:nvPr/>
+        </p:nvPicPr>
+        <p:blipFill>
+          <a:blip r:embed="rId2">
+            <a:extLst>
+              <a:ext uri="{28A0092B-C50C-407E-A947-70E740481C1C}">
+                <a14:useLocalDpi xmlns:a14="http://schemas.microsoft.com/office/drawing/2010/main" val="0"/>
+              </a:ext>
+            </a:extLst>
+          </a:blip>
+          <a:srcRect/>
+          <a:stretch/>
+        </p:blipFill>
+        <p:spPr bwMode="auto">
+          <a:xfrm>
+            <a:off x="2364988" y="949059"/>
+            <a:ext cx="7244233" cy="4191379"/>
+          </a:xfrm>
+          <a:prstGeom prst="rect">
+            <a:avLst/>
+          </a:prstGeom>
+          <a:noFill/>
+          <a:extLst>
+            <a:ext uri="{909E8E84-426E-40DD-AFC4-6F175D3DCCD1}">
+              <a14:hiddenFill xmlns:a14="http://schemas.microsoft.com/office/drawing/2010/main">
+                <a:solidFill>
+                  <a:srgbClr val="FFFFFF"/>
+                </a:solidFill>
+              </a14:hiddenFill>
+            </a:ext>
+          </a:extLst>
+        </p:spPr>
+      </p:pic>
+      <p:sp>
+        <p:nvSpPr>
+          <p:cNvPr id="7" name="Rectangle 6">
+            <a:extLst>
+              <a:ext uri="{FF2B5EF4-FFF2-40B4-BE49-F238E27FC236}">
+                <a16:creationId xmlns:a16="http://schemas.microsoft.com/office/drawing/2014/main" id="{FED29414-9B7A-85F2-B7C8-E74AB009AD4E}"/>
+              </a:ext>
+            </a:extLst>
+          </p:cNvPr>
+          <p:cNvSpPr/>
+          <p:nvPr/>
+        </p:nvSpPr>
+        <p:spPr>
+          <a:xfrm>
+            <a:off x="2629768" y="25729"/>
+            <a:ext cx="6723957" cy="923330"/>
           </a:xfrm>
           <a:prstGeom prst="rect">
             <a:avLst/>
@@ -3640,89 +3740,56 @@
                   </a:outerShdw>
                 </a:effectLst>
               </a:rPr>
-              <a:t>Clubs Tickets</a:t>
-            </a:r>
+              <a:t>Initiation à </a:t>
+            </a:r>
+            <a:r>
+              <a:rPr lang="fr-FR" sz="5400" b="1" dirty="0" err="1">
+                <a:ln w="10160">
+                  <a:solidFill>
+                    <a:schemeClr val="tx1"/>
+                  </a:solidFill>
+                  <a:prstDash val="solid"/>
+                </a:ln>
+                <a:solidFill>
+                  <a:srgbClr val="FFFFFF"/>
+                </a:solidFill>
+                <a:effectLst>
+                  <a:outerShdw blurRad="50800" dist="38100" dir="2700000" algn="tl" rotWithShape="0">
+                    <a:prstClr val="black">
+                      <a:alpha val="40000"/>
+                    </a:prstClr>
+                  </a:outerShdw>
+                </a:effectLst>
+              </a:rPr>
+              <a:t>Terraform</a:t>
+            </a:r>
+            <a:endParaRPr lang="fr-FR" sz="5400" b="1" dirty="0">
+              <a:ln w="10160">
+                <a:solidFill>
+                  <a:schemeClr val="tx1"/>
+                </a:solidFill>
+                <a:prstDash val="solid"/>
+              </a:ln>
+              <a:solidFill>
+                <a:srgbClr val="FFFFFF"/>
+              </a:solidFill>
+              <a:effectLst>
+                <a:outerShdw blurRad="50800" dist="38100" dir="2700000" algn="tl" rotWithShape="0">
+                  <a:prstClr val="black">
+                    <a:alpha val="40000"/>
+                  </a:prstClr>
+                </a:outerShdw>
+              </a:effectLst>
+            </a:endParaRPr>
           </a:p>
         </p:txBody>
       </p:sp>
       <p:pic>
         <p:nvPicPr>
-          <p:cNvPr id="18" name="Image 17">
-            <a:extLst>
-              <a:ext uri="{FF2B5EF4-FFF2-40B4-BE49-F238E27FC236}">
-                <a16:creationId xmlns:a16="http://schemas.microsoft.com/office/drawing/2014/main" id="{A97ED97E-7F92-E0B6-6D70-C1C4BBFF9006}"/>
-              </a:ext>
-            </a:extLst>
-          </p:cNvPr>
-          <p:cNvPicPr>
-            <a:picLocks noChangeAspect="1"/>
-          </p:cNvPicPr>
-          <p:nvPr/>
-        </p:nvPicPr>
-        <p:blipFill>
-          <a:blip r:embed="rId2">
-            <a:extLst>
-              <a:ext uri="{28A0092B-C50C-407E-A947-70E740481C1C}">
-                <a14:useLocalDpi xmlns:a14="http://schemas.microsoft.com/office/drawing/2010/main" val="0"/>
-              </a:ext>
-            </a:extLst>
-          </a:blip>
-          <a:stretch>
-            <a:fillRect/>
-          </a:stretch>
-        </p:blipFill>
-        <p:spPr>
-          <a:xfrm>
-            <a:off x="6865909" y="5439786"/>
-            <a:ext cx="1121527" cy="1171891"/>
-          </a:xfrm>
-          <a:prstGeom prst="rect">
-            <a:avLst/>
-          </a:prstGeom>
-        </p:spPr>
-      </p:pic>
-      <p:pic>
-        <p:nvPicPr>
-          <p:cNvPr id="20" name="Image 19">
-            <a:extLst>
-              <a:ext uri="{FF2B5EF4-FFF2-40B4-BE49-F238E27FC236}">
-                <a16:creationId xmlns:a16="http://schemas.microsoft.com/office/drawing/2014/main" id="{68E64A4C-78E1-E7A1-3722-F1701C5A5FA5}"/>
-              </a:ext>
-            </a:extLst>
-          </p:cNvPr>
-          <p:cNvPicPr>
-            <a:picLocks noChangeAspect="1"/>
-          </p:cNvPicPr>
-          <p:nvPr/>
-        </p:nvPicPr>
-        <p:blipFill>
-          <a:blip r:embed="rId3">
-            <a:extLst>
-              <a:ext uri="{28A0092B-C50C-407E-A947-70E740481C1C}">
-                <a14:useLocalDpi xmlns:a14="http://schemas.microsoft.com/office/drawing/2010/main" val="0"/>
-              </a:ext>
-            </a:extLst>
-          </a:blip>
-          <a:stretch>
-            <a:fillRect/>
-          </a:stretch>
-        </p:blipFill>
-        <p:spPr>
-          <a:xfrm>
-            <a:off x="3818449" y="5312961"/>
-            <a:ext cx="1300945" cy="1425540"/>
-          </a:xfrm>
-          <a:prstGeom prst="rect">
-            <a:avLst/>
-          </a:prstGeom>
-        </p:spPr>
-      </p:pic>
-      <p:pic>
-        <p:nvPicPr>
-          <p:cNvPr id="13316" name="Picture 4" descr="What is Web Scraping? | Practical Uses &amp; Methods">
-            <a:extLst>
-              <a:ext uri="{FF2B5EF4-FFF2-40B4-BE49-F238E27FC236}">
-                <a16:creationId xmlns:a16="http://schemas.microsoft.com/office/drawing/2014/main" id="{659C925D-E740-E84A-577B-C42F00BF5132}"/>
+          <p:cNvPr id="12" name="Picture 2" descr="Amazon Web Services Logo, symbol, meaning, history, PNG, brand">
+            <a:extLst>
+              <a:ext uri="{FF2B5EF4-FFF2-40B4-BE49-F238E27FC236}">
+                <a16:creationId xmlns:a16="http://schemas.microsoft.com/office/drawing/2014/main" id="{47CFCBAD-DE3A-292E-1111-FEF283156AE6}"/>
               </a:ext>
             </a:extLst>
           </p:cNvPr>
@@ -3732,7 +3799,7 @@
           <p:nvPr/>
         </p:nvPicPr>
         <p:blipFill>
-          <a:blip r:embed="rId4">
+          <a:blip r:embed="rId3">
             <a:extLst>
               <a:ext uri="{28A0092B-C50C-407E-A947-70E740481C1C}">
                 <a14:useLocalDpi xmlns:a14="http://schemas.microsoft.com/office/drawing/2010/main" val="0"/>
@@ -3746,8 +3813,102 @@
         </p:blipFill>
         <p:spPr bwMode="auto">
           <a:xfrm>
-            <a:off x="1957137" y="949059"/>
-            <a:ext cx="8277726" cy="4335952"/>
+            <a:off x="1946486" y="5195067"/>
+            <a:ext cx="2577387" cy="1449780"/>
+          </a:xfrm>
+          <a:prstGeom prst="rect">
+            <a:avLst/>
+          </a:prstGeom>
+          <a:noFill/>
+          <a:extLst>
+            <a:ext uri="{909E8E84-426E-40DD-AFC4-6F175D3DCCD1}">
+              <a14:hiddenFill xmlns:a14="http://schemas.microsoft.com/office/drawing/2010/main">
+                <a:solidFill>
+                  <a:srgbClr val="FFFFFF"/>
+                </a:solidFill>
+              </a14:hiddenFill>
+            </a:ext>
+          </a:extLst>
+        </p:spPr>
+      </p:pic>
+      <p:pic>
+        <p:nvPicPr>
+          <p:cNvPr id="13" name="Picture 4" descr="Download HD Hashicorp Terraform Logo Transparent PNG Image - NicePNG.com">
+            <a:extLst>
+              <a:ext uri="{FF2B5EF4-FFF2-40B4-BE49-F238E27FC236}">
+                <a16:creationId xmlns:a16="http://schemas.microsoft.com/office/drawing/2014/main" id="{13DC7EDA-6555-E3CD-3A78-42131247B676}"/>
+              </a:ext>
+            </a:extLst>
+          </p:cNvPr>
+          <p:cNvPicPr>
+            <a:picLocks noChangeAspect="1" noChangeArrowheads="1"/>
+          </p:cNvPicPr>
+          <p:nvPr/>
+        </p:nvPicPr>
+        <p:blipFill>
+          <a:blip r:embed="rId4">
+            <a:extLst>
+              <a:ext uri="{28A0092B-C50C-407E-A947-70E740481C1C}">
+                <a14:useLocalDpi xmlns:a14="http://schemas.microsoft.com/office/drawing/2010/main" val="0"/>
+              </a:ext>
+            </a:extLst>
+          </a:blip>
+          <a:srcRect/>
+          <a:stretch>
+            <a:fillRect/>
+          </a:stretch>
+        </p:blipFill>
+        <p:spPr bwMode="auto">
+          <a:xfrm>
+            <a:off x="5084830" y="5190295"/>
+            <a:ext cx="1529908" cy="1507872"/>
+          </a:xfrm>
+          <a:prstGeom prst="rect">
+            <a:avLst/>
+          </a:prstGeom>
+          <a:noFill/>
+          <a:extLst>
+            <a:ext uri="{909E8E84-426E-40DD-AFC4-6F175D3DCCD1}">
+              <a14:hiddenFill xmlns:a14="http://schemas.microsoft.com/office/drawing/2010/main">
+                <a:solidFill>
+                  <a:srgbClr val="FFFFFF"/>
+                </a:solidFill>
+              </a14:hiddenFill>
+            </a:ext>
+          </a:extLst>
+        </p:spPr>
+      </p:pic>
+      <p:pic>
+        <p:nvPicPr>
+          <p:cNvPr id="14" name="Picture 10">
+            <a:extLst>
+              <a:ext uri="{FF2B5EF4-FFF2-40B4-BE49-F238E27FC236}">
+                <a16:creationId xmlns:a16="http://schemas.microsoft.com/office/drawing/2014/main" id="{1CB93A31-EE62-CD2D-923C-DF517A4667C1}"/>
+              </a:ext>
+            </a:extLst>
+          </p:cNvPr>
+          <p:cNvPicPr>
+            <a:picLocks noChangeAspect="1" noChangeArrowheads="1"/>
+          </p:cNvPicPr>
+          <p:nvPr/>
+        </p:nvPicPr>
+        <p:blipFill>
+          <a:blip r:embed="rId5">
+            <a:extLst>
+              <a:ext uri="{28A0092B-C50C-407E-A947-70E740481C1C}">
+                <a14:useLocalDpi xmlns:a14="http://schemas.microsoft.com/office/drawing/2010/main" val="0"/>
+              </a:ext>
+            </a:extLst>
+          </a:blip>
+          <a:srcRect/>
+          <a:stretch>
+            <a:fillRect/>
+          </a:stretch>
+        </p:blipFill>
+        <p:spPr bwMode="auto">
+          <a:xfrm>
+            <a:off x="7342281" y="5310091"/>
+            <a:ext cx="2577387" cy="1077267"/>
           </a:xfrm>
           <a:prstGeom prst="rect">
             <a:avLst/>
@@ -3767,7 +3928,7 @@
     </p:spTree>
     <p:extLst>
       <p:ext uri="{BB962C8B-B14F-4D97-AF65-F5344CB8AC3E}">
-        <p14:creationId xmlns:p14="http://schemas.microsoft.com/office/powerpoint/2010/main" val="745894094"/>
+        <p14:creationId xmlns:p14="http://schemas.microsoft.com/office/powerpoint/2010/main" val="3880345932"/>
       </p:ext>
     </p:extLst>
   </p:cSld>

</xml_diff>

<commit_message>
project Images Fullscreen & corrrection project image3 Audit IT
</commit_message>
<xml_diff>
--- a/assets/project/project.pptx
+++ b/assets/project/project.pptx
@@ -260,7 +260,7 @@
           <a:p>
             <a:fld id="{045D4A40-7BDB-4F70-A797-96ACB408B356}" type="datetimeFigureOut">
               <a:rPr lang="fr-FR" smtClean="0"/>
-              <a:t>15/11/2025</a:t>
+              <a:t>08/02/2026</a:t>
             </a:fld>
             <a:endParaRPr lang="fr-FR"/>
           </a:p>
@@ -458,7 +458,7 @@
           <a:p>
             <a:fld id="{045D4A40-7BDB-4F70-A797-96ACB408B356}" type="datetimeFigureOut">
               <a:rPr lang="fr-FR" smtClean="0"/>
-              <a:t>15/11/2025</a:t>
+              <a:t>08/02/2026</a:t>
             </a:fld>
             <a:endParaRPr lang="fr-FR"/>
           </a:p>
@@ -666,7 +666,7 @@
           <a:p>
             <a:fld id="{045D4A40-7BDB-4F70-A797-96ACB408B356}" type="datetimeFigureOut">
               <a:rPr lang="fr-FR" smtClean="0"/>
-              <a:t>15/11/2025</a:t>
+              <a:t>08/02/2026</a:t>
             </a:fld>
             <a:endParaRPr lang="fr-FR"/>
           </a:p>
@@ -864,7 +864,7 @@
           <a:p>
             <a:fld id="{045D4A40-7BDB-4F70-A797-96ACB408B356}" type="datetimeFigureOut">
               <a:rPr lang="fr-FR" smtClean="0"/>
-              <a:t>15/11/2025</a:t>
+              <a:t>08/02/2026</a:t>
             </a:fld>
             <a:endParaRPr lang="fr-FR"/>
           </a:p>
@@ -1139,7 +1139,7 @@
           <a:p>
             <a:fld id="{045D4A40-7BDB-4F70-A797-96ACB408B356}" type="datetimeFigureOut">
               <a:rPr lang="fr-FR" smtClean="0"/>
-              <a:t>15/11/2025</a:t>
+              <a:t>08/02/2026</a:t>
             </a:fld>
             <a:endParaRPr lang="fr-FR"/>
           </a:p>
@@ -1404,7 +1404,7 @@
           <a:p>
             <a:fld id="{045D4A40-7BDB-4F70-A797-96ACB408B356}" type="datetimeFigureOut">
               <a:rPr lang="fr-FR" smtClean="0"/>
-              <a:t>15/11/2025</a:t>
+              <a:t>08/02/2026</a:t>
             </a:fld>
             <a:endParaRPr lang="fr-FR"/>
           </a:p>
@@ -1816,7 +1816,7 @@
           <a:p>
             <a:fld id="{045D4A40-7BDB-4F70-A797-96ACB408B356}" type="datetimeFigureOut">
               <a:rPr lang="fr-FR" smtClean="0"/>
-              <a:t>15/11/2025</a:t>
+              <a:t>08/02/2026</a:t>
             </a:fld>
             <a:endParaRPr lang="fr-FR"/>
           </a:p>
@@ -1957,7 +1957,7 @@
           <a:p>
             <a:fld id="{045D4A40-7BDB-4F70-A797-96ACB408B356}" type="datetimeFigureOut">
               <a:rPr lang="fr-FR" smtClean="0"/>
-              <a:t>15/11/2025</a:t>
+              <a:t>08/02/2026</a:t>
             </a:fld>
             <a:endParaRPr lang="fr-FR"/>
           </a:p>
@@ -2070,7 +2070,7 @@
           <a:p>
             <a:fld id="{045D4A40-7BDB-4F70-A797-96ACB408B356}" type="datetimeFigureOut">
               <a:rPr lang="fr-FR" smtClean="0"/>
-              <a:t>15/11/2025</a:t>
+              <a:t>08/02/2026</a:t>
             </a:fld>
             <a:endParaRPr lang="fr-FR"/>
           </a:p>
@@ -2381,7 +2381,7 @@
           <a:p>
             <a:fld id="{045D4A40-7BDB-4F70-A797-96ACB408B356}" type="datetimeFigureOut">
               <a:rPr lang="fr-FR" smtClean="0"/>
-              <a:t>15/11/2025</a:t>
+              <a:t>08/02/2026</a:t>
             </a:fld>
             <a:endParaRPr lang="fr-FR"/>
           </a:p>
@@ -2669,7 +2669,7 @@
           <a:p>
             <a:fld id="{045D4A40-7BDB-4F70-A797-96ACB408B356}" type="datetimeFigureOut">
               <a:rPr lang="fr-FR" smtClean="0"/>
-              <a:t>15/11/2025</a:t>
+              <a:t>08/02/2026</a:t>
             </a:fld>
             <a:endParaRPr lang="fr-FR"/>
           </a:p>
@@ -2910,7 +2910,7 @@
           <a:p>
             <a:fld id="{045D4A40-7BDB-4F70-A797-96ACB408B356}" type="datetimeFigureOut">
               <a:rPr lang="fr-FR" smtClean="0"/>
-              <a:t>15/11/2025</a:t>
+              <a:t>08/02/2026</a:t>
             </a:fld>
             <a:endParaRPr lang="fr-FR"/>
           </a:p>
@@ -3706,8 +3706,8 @@
         </p:nvSpPr>
         <p:spPr>
           <a:xfrm>
-            <a:off x="2629768" y="25729"/>
-            <a:ext cx="6723957" cy="923330"/>
+            <a:off x="2590020" y="25729"/>
+            <a:ext cx="6803466" cy="923330"/>
           </a:xfrm>
           <a:prstGeom prst="rect">
             <a:avLst/>
@@ -3740,47 +3740,8 @@
                   </a:outerShdw>
                 </a:effectLst>
               </a:rPr>
-              <a:t>Initiation à </a:t>
-            </a:r>
-            <a:r>
-              <a:rPr lang="fr-FR" sz="5400" b="1" dirty="0" err="1">
-                <a:ln w="10160">
-                  <a:solidFill>
-                    <a:schemeClr val="tx1"/>
-                  </a:solidFill>
-                  <a:prstDash val="solid"/>
-                </a:ln>
-                <a:solidFill>
-                  <a:srgbClr val="FFFFFF"/>
-                </a:solidFill>
-                <a:effectLst>
-                  <a:outerShdw blurRad="50800" dist="38100" dir="2700000" algn="tl" rotWithShape="0">
-                    <a:prstClr val="black">
-                      <a:alpha val="40000"/>
-                    </a:prstClr>
-                  </a:outerShdw>
-                </a:effectLst>
-              </a:rPr>
-              <a:t>Terraform</a:t>
-            </a:r>
-            <a:endParaRPr lang="fr-FR" sz="5400" b="1" dirty="0">
-              <a:ln w="10160">
-                <a:solidFill>
-                  <a:schemeClr val="tx1"/>
-                </a:solidFill>
-                <a:prstDash val="solid"/>
-              </a:ln>
-              <a:solidFill>
-                <a:srgbClr val="FFFFFF"/>
-              </a:solidFill>
-              <a:effectLst>
-                <a:outerShdw blurRad="50800" dist="38100" dir="2700000" algn="tl" rotWithShape="0">
-                  <a:prstClr val="black">
-                    <a:alpha val="40000"/>
-                  </a:prstClr>
-                </a:outerShdw>
-              </a:effectLst>
-            </a:endParaRPr>
+              <a:t>Cartographie Audit IT</a:t>
+            </a:r>
           </a:p>
         </p:txBody>
       </p:sp>

</xml_diff>